<commit_message>
CYSPA: Platzhalter Tabletop gefuellt, Freigabeliste als Word, Daily Notes
Angaben LWE 28.09.: bis 10 Personen, Offerte nach Vorgespraech, vor Ort,
5 Arbeitstage, Vertraulichkeitsvereinbarung Standard. Flyer (PDF, PPTX)
und Landingpage nachgefuehrt. Kalendereintraege als Nigel-Aufgabe
beantragt, warten auf Freigabe.

Co-Authored-By: Claude Opus 5.5 <noreply@anthropic.com>
Claude-Session: https://claude.ai/code/session_01JsQoSQbozeyt2EYitpEXuf
</commit_message>
<xml_diff>
--- a/cyspa-marketing/web/flyer-tabletop.pptx
+++ b/cyspa-marketing/web/flyer-tabletop.pptx
@@ -3275,7 +3275,7 @@
                 <a:ea typeface="Calibri" pitchFamily="34" charset="-122"/>
                 <a:cs typeface="Calibri" pitchFamily="34" charset="-120"/>
               </a:rPr>
-              <a:t>Was in der Übung besprochen wird, bleibt vertraulich</a:t>
+              <a:t>Vertraulich: Eine Vertraulichkeitsvereinbarung ist bei jeder Übung Standard</a:t>
             </a:r>
             <a:endParaRPr lang="en-US" sz="950" dirty="0"/>
           </a:p>
@@ -4714,7 +4714,7 @@
                 <a:ea typeface="Calibri" pitchFamily="34" charset="-122"/>
                 <a:cs typeface="Calibri" pitchFamily="34" charset="-120"/>
               </a:rPr>
-              <a:t>Geschäftsleitung, dazu je nach Organisation IT-Verantwortliche und Kommunikation.</a:t>
+              <a:t>Geschäftsleitung, dazu je nach Organisation IT-Verantwortliche und Kommunikation. Bis 10 Personen.</a:t>
             </a:r>
             <a:endParaRPr lang="en-US" sz="850" dirty="0"/>
           </a:p>
@@ -4722,51 +4722,7 @@
       </p:sp>
       <p:sp>
         <p:nvSpPr>
-          <p:cNvPr id="31" name="Text 22"/>
-          <p:cNvSpPr txBox="1"/>
-          <p:nvPr/>
-        </p:nvSpPr>
-        <p:spPr>
-          <a:xfrm>
-            <a:off x="2971800" y="4709160"/>
-            <a:ext cx="1527048" cy="182880"/>
-          </a:xfrm>
-          <a:prstGeom prst="rect">
-            <a:avLst/>
-          </a:prstGeom>
-          <a:noFill/>
-          <a:ln w="9525">
-            <a:solidFill>
-              <a:srgbClr val="103157"/>
-            </a:solidFill>
-            <a:prstDash val="dash"/>
-          </a:ln>
-        </p:spPr>
-        <p:txBody>
-          <a:bodyPr wrap="square" lIns="12700" tIns="38100" rIns="38100" bIns="12700" rtlCol="0" anchor="ctr"/>
-          <a:lstStyle/>
-          <a:p>
-            <a:pPr indent="0" marL="0">
-              <a:buNone/>
-            </a:pPr>
-            <a:r>
-              <a:rPr lang="en-US" sz="800" b="1" dirty="0">
-                <a:solidFill>
-                  <a:srgbClr val="103157"/>
-                </a:solidFill>
-                <a:latin typeface="Calibri" pitchFamily="34" charset="0"/>
-                <a:ea typeface="Calibri" pitchFamily="34" charset="-122"/>
-                <a:cs typeface="Calibri" pitchFamily="34" charset="-120"/>
-              </a:rPr>
-              <a:t>[PLATZHALTER: Gruppengrösse]</a:t>
-            </a:r>
-            <a:endParaRPr lang="en-US" sz="800" dirty="0"/>
-          </a:p>
-        </p:txBody>
-      </p:sp>
-      <p:sp>
-        <p:nvSpPr>
-          <p:cNvPr id="32" name="Shape 23"/>
+          <p:cNvPr id="31" name="Shape 22"/>
           <p:cNvSpPr/>
           <p:nvPr/>
         </p:nvSpPr>
@@ -4798,7 +4754,7 @@
       </p:sp>
       <p:sp>
         <p:nvSpPr>
-          <p:cNvPr id="33" name="Shape 24"/>
+          <p:cNvPr id="32" name="Shape 23"/>
           <p:cNvSpPr/>
           <p:nvPr/>
         </p:nvSpPr>
@@ -4823,7 +4779,7 @@
       </p:sp>
       <p:pic>
         <p:nvPicPr>
-          <p:cNvPr id="34" name="Image 7" descr="Symbol">    </p:cNvPr>
+          <p:cNvPr id="33" name="Image 7" descr="Symbol">    </p:cNvPr>
           <p:cNvPicPr>
             <a:picLocks noChangeAspect="1"/>
           </p:cNvPicPr>
@@ -4847,7 +4803,7 @@
       </p:pic>
       <p:sp>
         <p:nvSpPr>
-          <p:cNvPr id="35" name="Text 25"/>
+          <p:cNvPr id="34" name="Text 24"/>
           <p:cNvSpPr txBox="1"/>
           <p:nvPr/>
         </p:nvSpPr>
@@ -4886,7 +4842,7 @@
       </p:sp>
       <p:sp>
         <p:nvSpPr>
-          <p:cNvPr id="36" name="Text 26"/>
+          <p:cNvPr id="35" name="Text 25"/>
           <p:cNvSpPr txBox="1"/>
           <p:nvPr/>
         </p:nvSpPr>
@@ -4925,7 +4881,7 @@
       </p:sp>
       <p:sp>
         <p:nvSpPr>
-          <p:cNvPr id="37" name="Text 27"/>
+          <p:cNvPr id="36" name="Text 26"/>
           <p:cNvSpPr txBox="1"/>
           <p:nvPr/>
         </p:nvSpPr>
@@ -4959,7 +4915,7 @@
                 <a:ea typeface="Calibri" pitchFamily="34" charset="-122"/>
                 <a:cs typeface="Calibri" pitchFamily="34" charset="-120"/>
               </a:rPr>
-              <a:t>Mit klaren Verantwortlichkeiten.</a:t>
+              <a:t>Mit klaren Verantwortlichkeiten, innert 5 Arbeitstagen nach der Übung.</a:t>
             </a:r>
             <a:endParaRPr lang="en-US" sz="850" dirty="0"/>
           </a:p>
@@ -4967,51 +4923,7 @@
       </p:sp>
       <p:sp>
         <p:nvSpPr>
-          <p:cNvPr id="38" name="Text 28"/>
-          <p:cNvSpPr txBox="1"/>
-          <p:nvPr/>
-        </p:nvSpPr>
-        <p:spPr>
-          <a:xfrm>
-            <a:off x="5093208" y="4709160"/>
-            <a:ext cx="1527048" cy="182880"/>
-          </a:xfrm>
-          <a:prstGeom prst="rect">
-            <a:avLst/>
-          </a:prstGeom>
-          <a:noFill/>
-          <a:ln w="9525">
-            <a:solidFill>
-              <a:srgbClr val="103157"/>
-            </a:solidFill>
-            <a:prstDash val="dash"/>
-          </a:ln>
-        </p:spPr>
-        <p:txBody>
-          <a:bodyPr wrap="square" lIns="12700" tIns="38100" rIns="38100" bIns="12700" rtlCol="0" anchor="ctr"/>
-          <a:lstStyle/>
-          <a:p>
-            <a:pPr indent="0" marL="0">
-              <a:buNone/>
-            </a:pPr>
-            <a:r>
-              <a:rPr lang="en-US" sz="800" b="1" dirty="0">
-                <a:solidFill>
-                  <a:srgbClr val="103157"/>
-                </a:solidFill>
-                <a:latin typeface="Calibri" pitchFamily="34" charset="0"/>
-                <a:ea typeface="Calibri" pitchFamily="34" charset="-122"/>
-                <a:cs typeface="Calibri" pitchFamily="34" charset="-120"/>
-              </a:rPr>
-              <a:t>[PLATZHALTER: Lieferfrist]</a:t>
-            </a:r>
-            <a:endParaRPr lang="en-US" sz="800" dirty="0"/>
-          </a:p>
-        </p:txBody>
-      </p:sp>
-      <p:sp>
-        <p:nvSpPr>
-          <p:cNvPr id="39" name="Text 29"/>
+          <p:cNvPr id="37" name="Text 27"/>
           <p:cNvSpPr txBox="1"/>
           <p:nvPr/>
         </p:nvSpPr>
@@ -5050,7 +4962,7 @@
       </p:sp>
       <p:sp>
         <p:nvSpPr>
-          <p:cNvPr id="40" name="Shape 30"/>
+          <p:cNvPr id="38" name="Shape 28"/>
           <p:cNvSpPr/>
           <p:nvPr/>
         </p:nvSpPr>
@@ -5075,7 +4987,7 @@
       </p:sp>
       <p:sp>
         <p:nvSpPr>
-          <p:cNvPr id="41" name="Shape 31"/>
+          <p:cNvPr id="39" name="Shape 29"/>
           <p:cNvSpPr/>
           <p:nvPr/>
         </p:nvSpPr>
@@ -5100,7 +5012,7 @@
       </p:sp>
       <p:sp>
         <p:nvSpPr>
-          <p:cNvPr id="42" name="Text 32"/>
+          <p:cNvPr id="40" name="Text 30"/>
           <p:cNvSpPr txBox="1"/>
           <p:nvPr/>
         </p:nvSpPr>
@@ -5139,7 +5051,7 @@
       </p:sp>
       <p:sp>
         <p:nvSpPr>
-          <p:cNvPr id="43" name="Text 33"/>
+          <p:cNvPr id="41" name="Text 31"/>
           <p:cNvSpPr txBox="1"/>
           <p:nvPr/>
         </p:nvSpPr>
@@ -5181,7 +5093,7 @@
       </p:sp>
       <p:sp>
         <p:nvSpPr>
-          <p:cNvPr id="44" name="Shape 34"/>
+          <p:cNvPr id="42" name="Shape 32"/>
           <p:cNvSpPr/>
           <p:nvPr/>
         </p:nvSpPr>
@@ -5206,7 +5118,7 @@
       </p:sp>
       <p:sp>
         <p:nvSpPr>
-          <p:cNvPr id="45" name="Shape 35"/>
+          <p:cNvPr id="43" name="Shape 33"/>
           <p:cNvSpPr/>
           <p:nvPr/>
         </p:nvSpPr>
@@ -5231,7 +5143,7 @@
       </p:sp>
       <p:sp>
         <p:nvSpPr>
-          <p:cNvPr id="46" name="Text 36"/>
+          <p:cNvPr id="44" name="Text 34"/>
           <p:cNvSpPr txBox="1"/>
           <p:nvPr/>
         </p:nvSpPr>
@@ -5270,7 +5182,7 @@
       </p:sp>
       <p:sp>
         <p:nvSpPr>
-          <p:cNvPr id="47" name="Text 37"/>
+          <p:cNvPr id="45" name="Text 35"/>
           <p:cNvSpPr txBox="1"/>
           <p:nvPr/>
         </p:nvSpPr>
@@ -5312,7 +5224,7 @@
       </p:sp>
       <p:sp>
         <p:nvSpPr>
-          <p:cNvPr id="48" name="Shape 38"/>
+          <p:cNvPr id="46" name="Shape 36"/>
           <p:cNvSpPr/>
           <p:nvPr/>
         </p:nvSpPr>
@@ -5337,7 +5249,7 @@
       </p:sp>
       <p:sp>
         <p:nvSpPr>
-          <p:cNvPr id="49" name="Shape 39"/>
+          <p:cNvPr id="47" name="Shape 37"/>
           <p:cNvSpPr/>
           <p:nvPr/>
         </p:nvSpPr>
@@ -5362,7 +5274,7 @@
       </p:sp>
       <p:sp>
         <p:nvSpPr>
-          <p:cNvPr id="50" name="Text 40"/>
+          <p:cNvPr id="48" name="Text 38"/>
           <p:cNvSpPr txBox="1"/>
           <p:nvPr/>
         </p:nvSpPr>
@@ -5401,7 +5313,7 @@
       </p:sp>
       <p:sp>
         <p:nvSpPr>
-          <p:cNvPr id="51" name="Text 41"/>
+          <p:cNvPr id="49" name="Text 39"/>
           <p:cNvSpPr txBox="1"/>
           <p:nvPr/>
         </p:nvSpPr>
@@ -5443,7 +5355,7 @@
       </p:sp>
       <p:sp>
         <p:nvSpPr>
-          <p:cNvPr id="52" name="Shape 42"/>
+          <p:cNvPr id="50" name="Shape 40"/>
           <p:cNvSpPr/>
           <p:nvPr/>
         </p:nvSpPr>
@@ -5468,7 +5380,7 @@
       </p:sp>
       <p:sp>
         <p:nvSpPr>
-          <p:cNvPr id="53" name="Shape 43"/>
+          <p:cNvPr id="51" name="Shape 41"/>
           <p:cNvSpPr/>
           <p:nvPr/>
         </p:nvSpPr>
@@ -5493,7 +5405,7 @@
       </p:sp>
       <p:sp>
         <p:nvSpPr>
-          <p:cNvPr id="54" name="Text 44"/>
+          <p:cNvPr id="52" name="Text 42"/>
           <p:cNvSpPr txBox="1"/>
           <p:nvPr/>
         </p:nvSpPr>
@@ -5532,7 +5444,7 @@
       </p:sp>
       <p:sp>
         <p:nvSpPr>
-          <p:cNvPr id="55" name="Text 45"/>
+          <p:cNvPr id="53" name="Text 43"/>
           <p:cNvSpPr txBox="1"/>
           <p:nvPr/>
         </p:nvSpPr>
@@ -5574,7 +5486,7 @@
       </p:sp>
       <p:sp>
         <p:nvSpPr>
-          <p:cNvPr id="56" name="Text 46"/>
+          <p:cNvPr id="54" name="Text 44"/>
           <p:cNvSpPr txBox="1"/>
           <p:nvPr/>
         </p:nvSpPr>
@@ -5613,7 +5525,7 @@
       </p:sp>
       <p:sp>
         <p:nvSpPr>
-          <p:cNvPr id="57" name="Shape 47"/>
+          <p:cNvPr id="55" name="Shape 45"/>
           <p:cNvSpPr/>
           <p:nvPr/>
         </p:nvSpPr>
@@ -5638,7 +5550,7 @@
       </p:sp>
       <p:sp>
         <p:nvSpPr>
-          <p:cNvPr id="58" name="Text 48"/>
+          <p:cNvPr id="56" name="Text 46"/>
           <p:cNvSpPr txBox="1"/>
           <p:nvPr/>
         </p:nvSpPr>
@@ -5677,7 +5589,7 @@
       </p:sp>
       <p:sp>
         <p:nvSpPr>
-          <p:cNvPr id="59" name="Text 49"/>
+          <p:cNvPr id="57" name="Text 47"/>
           <p:cNvSpPr txBox="1"/>
           <p:nvPr/>
         </p:nvSpPr>
@@ -5719,7 +5631,7 @@
       </p:sp>
       <p:sp>
         <p:nvSpPr>
-          <p:cNvPr id="60" name="Shape 50"/>
+          <p:cNvPr id="58" name="Shape 48"/>
           <p:cNvSpPr/>
           <p:nvPr/>
         </p:nvSpPr>
@@ -5744,7 +5656,7 @@
       </p:sp>
       <p:sp>
         <p:nvSpPr>
-          <p:cNvPr id="61" name="Text 51"/>
+          <p:cNvPr id="59" name="Text 49"/>
           <p:cNvSpPr txBox="1"/>
           <p:nvPr/>
         </p:nvSpPr>
@@ -5783,14 +5695,14 @@
       </p:sp>
       <p:sp>
         <p:nvSpPr>
-          <p:cNvPr id="62" name="Text 52"/>
+          <p:cNvPr id="60" name="Text 50"/>
           <p:cNvSpPr txBox="1"/>
           <p:nvPr/>
         </p:nvSpPr>
         <p:spPr>
           <a:xfrm>
             <a:off x="822960" y="7909560"/>
-            <a:ext cx="2926080" cy="265176"/>
+            <a:ext cx="2926080" cy="397764"/>
           </a:xfrm>
           <a:prstGeom prst="rect">
             <a:avLst/>
@@ -5817,7 +5729,7 @@
                 <a:ea typeface="Calibri" pitchFamily="34" charset="-122"/>
                 <a:cs typeface="Calibri" pitchFamily="34" charset="-120"/>
               </a:rPr>
-              <a:t>Ein realistisches, fiktives Szenario, zum Beispiel ein Ransomware-Angriff.</a:t>
+              <a:t>Ein realistisches, fiktives Szenario, zum Beispiel ein Ransomware-Angriff. Das Szenario wird im Vorgespräch auf Ihre Organisation zugeschnitten.</a:t>
             </a:r>
             <a:endParaRPr lang="en-US" sz="800" dirty="0"/>
           </a:p>
@@ -5825,51 +5737,7 @@
       </p:sp>
       <p:sp>
         <p:nvSpPr>
-          <p:cNvPr id="63" name="Text 53"/>
-          <p:cNvSpPr txBox="1"/>
-          <p:nvPr/>
-        </p:nvSpPr>
-        <p:spPr>
-          <a:xfrm>
-            <a:off x="822960" y="8202168"/>
-            <a:ext cx="1987906" cy="164592"/>
-          </a:xfrm>
-          <a:prstGeom prst="rect">
-            <a:avLst/>
-          </a:prstGeom>
-          <a:noFill/>
-          <a:ln w="9525">
-            <a:solidFill>
-              <a:srgbClr val="103157"/>
-            </a:solidFill>
-            <a:prstDash val="dash"/>
-          </a:ln>
-        </p:spPr>
-        <p:txBody>
-          <a:bodyPr wrap="square" lIns="12700" tIns="38100" rIns="38100" bIns="12700" rtlCol="0" anchor="ctr"/>
-          <a:lstStyle/>
-          <a:p>
-            <a:pPr indent="0" marL="0">
-              <a:buNone/>
-            </a:pPr>
-            <a:r>
-              <a:rPr lang="en-US" sz="800" b="1" dirty="0">
-                <a:solidFill>
-                  <a:srgbClr val="103157"/>
-                </a:solidFill>
-                <a:latin typeface="Calibri" pitchFamily="34" charset="0"/>
-                <a:ea typeface="Calibri" pitchFamily="34" charset="-122"/>
-                <a:cs typeface="Calibri" pitchFamily="34" charset="-120"/>
-              </a:rPr>
-              <a:t>[PLATZHALTER: Zuschnitt auf Branche?]</a:t>
-            </a:r>
-            <a:endParaRPr lang="en-US" sz="800" dirty="0"/>
-          </a:p>
-        </p:txBody>
-      </p:sp>
-      <p:sp>
-        <p:nvSpPr>
-          <p:cNvPr id="64" name="Shape 54"/>
+          <p:cNvPr id="61" name="Shape 51"/>
           <p:cNvSpPr/>
           <p:nvPr/>
         </p:nvSpPr>
@@ -5894,7 +5762,7 @@
       </p:sp>
       <p:sp>
         <p:nvSpPr>
-          <p:cNvPr id="65" name="Text 55"/>
+          <p:cNvPr id="62" name="Text 52"/>
           <p:cNvSpPr txBox="1"/>
           <p:nvPr/>
         </p:nvSpPr>
@@ -5933,7 +5801,7 @@
       </p:sp>
       <p:sp>
         <p:nvSpPr>
-          <p:cNvPr id="66" name="Text 56"/>
+          <p:cNvPr id="63" name="Text 53"/>
           <p:cNvSpPr txBox="1"/>
           <p:nvPr/>
         </p:nvSpPr>
@@ -5975,7 +5843,7 @@
       </p:sp>
       <p:sp>
         <p:nvSpPr>
-          <p:cNvPr id="67" name="Shape 57"/>
+          <p:cNvPr id="64" name="Shape 54"/>
           <p:cNvSpPr/>
           <p:nvPr/>
         </p:nvSpPr>
@@ -6000,7 +5868,7 @@
       </p:sp>
       <p:sp>
         <p:nvSpPr>
-          <p:cNvPr id="68" name="Text 58"/>
+          <p:cNvPr id="65" name="Text 55"/>
           <p:cNvSpPr txBox="1"/>
           <p:nvPr/>
         </p:nvSpPr>
@@ -6039,43 +5907,41 @@
       </p:sp>
       <p:sp>
         <p:nvSpPr>
-          <p:cNvPr id="69" name="Text 59"/>
+          <p:cNvPr id="66" name="Text 56"/>
           <p:cNvSpPr txBox="1"/>
           <p:nvPr/>
         </p:nvSpPr>
         <p:spPr>
           <a:xfrm>
             <a:off x="4023360" y="7205472"/>
-            <a:ext cx="2653589" cy="164592"/>
-          </a:xfrm>
-          <a:prstGeom prst="rect">
-            <a:avLst/>
-          </a:prstGeom>
-          <a:noFill/>
-          <a:ln w="9525">
-            <a:solidFill>
-              <a:srgbClr val="103157"/>
-            </a:solidFill>
-            <a:prstDash val="dash"/>
-          </a:ln>
-        </p:spPr>
-        <p:txBody>
-          <a:bodyPr wrap="square" lIns="12700" tIns="38100" rIns="38100" bIns="12700" rtlCol="0" anchor="ctr"/>
-          <a:lstStyle/>
-          <a:p>
-            <a:pPr indent="0" marL="0">
-              <a:buNone/>
-            </a:pPr>
-            <a:r>
-              <a:rPr lang="en-US" sz="800" b="1" dirty="0">
-                <a:solidFill>
-                  <a:srgbClr val="103157"/>
+            <a:ext cx="2926080" cy="132588"/>
+          </a:xfrm>
+          <a:prstGeom prst="rect">
+            <a:avLst/>
+          </a:prstGeom>
+          <a:noFill/>
+          <a:ln/>
+        </p:spPr>
+        <p:txBody>
+          <a:bodyPr wrap="square" lIns="0" tIns="0" rIns="0" bIns="0" rtlCol="0" anchor="t"/>
+          <a:lstStyle/>
+          <a:p>
+            <a:pPr indent="0" marL="0">
+              <a:lnSpc>
+                <a:spcPct val="100000"/>
+              </a:lnSpc>
+              <a:buNone/>
+            </a:pPr>
+            <a:r>
+              <a:rPr lang="en-US" sz="800" dirty="0">
+                <a:solidFill>
+                  <a:srgbClr val="5A5A5A"/>
                 </a:solidFill>
                 <a:latin typeface="Calibri" pitchFamily="34" charset="0"/>
                 <a:ea typeface="Calibri" pitchFamily="34" charset="-122"/>
                 <a:cs typeface="Calibri" pitchFamily="34" charset="-120"/>
               </a:rPr>
-              <a:t>[PLATZHALTER: vor Ort, in Rotkreuz und/oder online]</a:t>
+              <a:t>Bei Ihnen vor Ort.</a:t>
             </a:r>
             <a:endParaRPr lang="en-US" sz="800" dirty="0"/>
           </a:p>
@@ -6083,7 +5949,7 @@
       </p:sp>
       <p:sp>
         <p:nvSpPr>
-          <p:cNvPr id="70" name="Shape 60"/>
+          <p:cNvPr id="67" name="Shape 57"/>
           <p:cNvSpPr/>
           <p:nvPr/>
         </p:nvSpPr>
@@ -6108,7 +5974,7 @@
       </p:sp>
       <p:sp>
         <p:nvSpPr>
-          <p:cNvPr id="71" name="Text 61"/>
+          <p:cNvPr id="68" name="Text 58"/>
           <p:cNvSpPr txBox="1"/>
           <p:nvPr/>
         </p:nvSpPr>
@@ -6147,14 +6013,14 @@
       </p:sp>
       <p:sp>
         <p:nvSpPr>
-          <p:cNvPr id="72" name="Text 62"/>
+          <p:cNvPr id="69" name="Text 59"/>
           <p:cNvSpPr txBox="1"/>
           <p:nvPr/>
         </p:nvSpPr>
         <p:spPr>
           <a:xfrm>
             <a:off x="4023360" y="7909560"/>
-            <a:ext cx="2926080" cy="132588"/>
+            <a:ext cx="2926080" cy="265176"/>
           </a:xfrm>
           <a:prstGeom prst="rect">
             <a:avLst/>
@@ -6181,7 +6047,7 @@
                 <a:ea typeface="Calibri" pitchFamily="34" charset="-122"/>
                 <a:cs typeface="Calibri" pitchFamily="34" charset="-120"/>
               </a:rPr>
-              <a:t>Was in der Übung besprochen wird, bleibt vertraulich.</a:t>
+              <a:t>Was in der Übung besprochen wird, bleibt vertraulich. Eine Vertraulichkeitsvereinbarung ist bei jeder Übung Standard.</a:t>
             </a:r>
             <a:endParaRPr lang="en-US" sz="800" dirty="0"/>
           </a:p>
@@ -6189,51 +6055,7 @@
       </p:sp>
       <p:sp>
         <p:nvSpPr>
-          <p:cNvPr id="73" name="Text 63"/>
-          <p:cNvSpPr txBox="1"/>
-          <p:nvPr/>
-        </p:nvSpPr>
-        <p:spPr>
-          <a:xfrm>
-            <a:off x="4023360" y="8069580"/>
-            <a:ext cx="2320747" cy="164592"/>
-          </a:xfrm>
-          <a:prstGeom prst="rect">
-            <a:avLst/>
-          </a:prstGeom>
-          <a:noFill/>
-          <a:ln w="9525">
-            <a:solidFill>
-              <a:srgbClr val="103157"/>
-            </a:solidFill>
-            <a:prstDash val="dash"/>
-          </a:ln>
-        </p:spPr>
-        <p:txBody>
-          <a:bodyPr wrap="square" lIns="12700" tIns="38100" rIns="38100" bIns="12700" rtlCol="0" anchor="ctr"/>
-          <a:lstStyle/>
-          <a:p>
-            <a:pPr indent="0" marL="0">
-              <a:buNone/>
-            </a:pPr>
-            <a:r>
-              <a:rPr lang="en-US" sz="800" b="1" dirty="0">
-                <a:solidFill>
-                  <a:srgbClr val="103157"/>
-                </a:solidFill>
-                <a:latin typeface="Calibri" pitchFamily="34" charset="0"/>
-                <a:ea typeface="Calibri" pitchFamily="34" charset="-122"/>
-                <a:cs typeface="Calibri" pitchFamily="34" charset="-120"/>
-              </a:rPr>
-              <a:t>[PLATZHALTER: Vertraulichkeitsvereinbarung?]</a:t>
-            </a:r>
-            <a:endParaRPr lang="en-US" sz="800" dirty="0"/>
-          </a:p>
-        </p:txBody>
-      </p:sp>
-      <p:sp>
-        <p:nvSpPr>
-          <p:cNvPr id="74" name="Shape 64"/>
+          <p:cNvPr id="70" name="Shape 60"/>
           <p:cNvSpPr/>
           <p:nvPr/>
         </p:nvSpPr>
@@ -6258,7 +6080,7 @@
       </p:sp>
       <p:sp>
         <p:nvSpPr>
-          <p:cNvPr id="75" name="Text 65"/>
+          <p:cNvPr id="71" name="Text 61"/>
           <p:cNvSpPr txBox="1"/>
           <p:nvPr/>
         </p:nvSpPr>
@@ -6297,43 +6119,41 @@
       </p:sp>
       <p:sp>
         <p:nvSpPr>
-          <p:cNvPr id="76" name="Text 66"/>
+          <p:cNvPr id="72" name="Text 62"/>
           <p:cNvSpPr txBox="1"/>
           <p:nvPr/>
         </p:nvSpPr>
         <p:spPr>
           <a:xfrm>
             <a:off x="4023360" y="8613648"/>
-            <a:ext cx="2701138" cy="164592"/>
-          </a:xfrm>
-          <a:prstGeom prst="rect">
-            <a:avLst/>
-          </a:prstGeom>
-          <a:noFill/>
-          <a:ln w="9525">
-            <a:solidFill>
-              <a:srgbClr val="103157"/>
-            </a:solidFill>
-            <a:prstDash val="dash"/>
-          </a:ln>
-        </p:spPr>
-        <p:txBody>
-          <a:bodyPr wrap="square" lIns="12700" tIns="38100" rIns="38100" bIns="12700" rtlCol="0" anchor="ctr"/>
-          <a:lstStyle/>
-          <a:p>
-            <a:pPr indent="0" marL="0">
-              <a:buNone/>
-            </a:pPr>
-            <a:r>
-              <a:rPr lang="en-US" sz="800" b="1" dirty="0">
-                <a:solidFill>
-                  <a:srgbClr val="103157"/>
+            <a:ext cx="2926080" cy="132588"/>
+          </a:xfrm>
+          <a:prstGeom prst="rect">
+            <a:avLst/>
+          </a:prstGeom>
+          <a:noFill/>
+          <a:ln/>
+        </p:spPr>
+        <p:txBody>
+          <a:bodyPr wrap="square" lIns="0" tIns="0" rIns="0" bIns="0" rtlCol="0" anchor="t"/>
+          <a:lstStyle/>
+          <a:p>
+            <a:pPr indent="0" marL="0">
+              <a:lnSpc>
+                <a:spcPct val="100000"/>
+              </a:lnSpc>
+              <a:buNone/>
+            </a:pPr>
+            <a:r>
+              <a:rPr lang="en-US" sz="800" dirty="0">
+                <a:solidFill>
+                  <a:srgbClr val="5A5A5A"/>
                 </a:solidFill>
                 <a:latin typeface="Calibri" pitchFamily="34" charset="0"/>
                 <a:ea typeface="Calibri" pitchFamily="34" charset="-122"/>
                 <a:cs typeface="Calibri" pitchFamily="34" charset="-120"/>
               </a:rPr>
-              <a:t>[PLATZHALTER: Preis oder «Offerte nach Vorgespräch»]</a:t>
+              <a:t>Nach dem Vorgespräch erhalten Sie eine Offerte.</a:t>
             </a:r>
             <a:endParaRPr lang="en-US" sz="800" dirty="0"/>
           </a:p>
@@ -6341,7 +6161,7 @@
       </p:sp>
       <p:sp>
         <p:nvSpPr>
-          <p:cNvPr id="77" name="Shape 67"/>
+          <p:cNvPr id="73" name="Shape 63"/>
           <p:cNvSpPr/>
           <p:nvPr/>
         </p:nvSpPr>
@@ -6366,7 +6186,7 @@
       </p:sp>
       <p:sp>
         <p:nvSpPr>
-          <p:cNvPr id="78" name="Shape 68"/>
+          <p:cNvPr id="74" name="Shape 64"/>
           <p:cNvSpPr/>
           <p:nvPr/>
         </p:nvSpPr>
@@ -6391,7 +6211,7 @@
       </p:sp>
       <p:sp>
         <p:nvSpPr>
-          <p:cNvPr id="79" name="Shape 69"/>
+          <p:cNvPr id="75" name="Shape 65"/>
           <p:cNvSpPr/>
           <p:nvPr/>
         </p:nvSpPr>
@@ -6416,7 +6236,7 @@
       </p:sp>
       <p:sp>
         <p:nvSpPr>
-          <p:cNvPr id="80" name="Text 70"/>
+          <p:cNvPr id="76" name="Text 66"/>
           <p:cNvSpPr txBox="1"/>
           <p:nvPr/>
         </p:nvSpPr>
@@ -6455,7 +6275,7 @@
       </p:sp>
       <p:sp>
         <p:nvSpPr>
-          <p:cNvPr id="81" name="Text 71"/>
+          <p:cNvPr id="77" name="Text 67"/>
           <p:cNvSpPr txBox="1"/>
           <p:nvPr/>
         </p:nvSpPr>
@@ -6508,7 +6328,7 @@
       </p:sp>
       <p:sp>
         <p:nvSpPr>
-          <p:cNvPr id="82" name="Text 72"/>
+          <p:cNvPr id="78" name="Text 68"/>
           <p:cNvSpPr txBox="1"/>
           <p:nvPr/>
         </p:nvSpPr>
@@ -6547,7 +6367,7 @@
       </p:sp>
       <p:pic>
         <p:nvPicPr>
-          <p:cNvPr id="83" name="Image 8" descr="Symbol">    </p:cNvPr>
+          <p:cNvPr id="79" name="Image 8" descr="Symbol">    </p:cNvPr>
           <p:cNvPicPr>
             <a:picLocks noChangeAspect="1"/>
           </p:cNvPicPr>
@@ -6571,7 +6391,7 @@
       </p:pic>
       <p:sp>
         <p:nvSpPr>
-          <p:cNvPr id="84" name="Text 73"/>
+          <p:cNvPr id="80" name="Text 69"/>
           <p:cNvSpPr txBox="1"/>
           <p:nvPr/>
         </p:nvSpPr>
@@ -6610,7 +6430,7 @@
       </p:sp>
       <p:pic>
         <p:nvPicPr>
-          <p:cNvPr id="85" name="Image 9" descr="Symbol">    </p:cNvPr>
+          <p:cNvPr id="81" name="Image 9" descr="Symbol">    </p:cNvPr>
           <p:cNvPicPr>
             <a:picLocks noChangeAspect="1"/>
           </p:cNvPicPr>
@@ -6634,7 +6454,7 @@
       </p:pic>
       <p:sp>
         <p:nvSpPr>
-          <p:cNvPr id="86" name="Text 74"/>
+          <p:cNvPr id="82" name="Text 70"/>
           <p:cNvSpPr txBox="1"/>
           <p:nvPr/>
         </p:nvSpPr>
@@ -6673,7 +6493,7 @@
       </p:sp>
       <p:pic>
         <p:nvPicPr>
-          <p:cNvPr id="87" name="Image 10" descr="Symbol">    </p:cNvPr>
+          <p:cNvPr id="83" name="Image 10" descr="Symbol">    </p:cNvPr>
           <p:cNvPicPr>
             <a:picLocks noChangeAspect="1"/>
           </p:cNvPicPr>
@@ -6697,7 +6517,7 @@
       </p:pic>
       <p:sp>
         <p:nvSpPr>
-          <p:cNvPr id="88" name="Text 75"/>
+          <p:cNvPr id="84" name="Text 71"/>
           <p:cNvSpPr txBox="1"/>
           <p:nvPr/>
         </p:nvSpPr>
@@ -6736,7 +6556,7 @@
       </p:sp>
       <p:pic>
         <p:nvPicPr>
-          <p:cNvPr id="89" name="Image 11" descr="Symbol">    </p:cNvPr>
+          <p:cNvPr id="85" name="Image 11" descr="Symbol">    </p:cNvPr>
           <p:cNvPicPr>
             <a:picLocks noChangeAspect="1"/>
           </p:cNvPicPr>
@@ -6760,7 +6580,7 @@
       </p:pic>
       <p:sp>
         <p:nvSpPr>
-          <p:cNvPr id="90" name="Text 76"/>
+          <p:cNvPr id="86" name="Text 72"/>
           <p:cNvSpPr txBox="1"/>
           <p:nvPr/>
         </p:nvSpPr>
@@ -6799,7 +6619,7 @@
       </p:sp>
       <p:sp>
         <p:nvSpPr>
-          <p:cNvPr id="91" name="Shape 77"/>
+          <p:cNvPr id="87" name="Shape 73"/>
           <p:cNvSpPr/>
           <p:nvPr/>
         </p:nvSpPr>
@@ -6824,7 +6644,7 @@
       </p:sp>
       <p:pic>
         <p:nvPicPr>
-          <p:cNvPr id="92" name="Image 12" descr="Symbol">    </p:cNvPr>
+          <p:cNvPr id="88" name="Image 12" descr="Symbol">    </p:cNvPr>
           <p:cNvPicPr>
             <a:picLocks noChangeAspect="1"/>
           </p:cNvPicPr>
@@ -6848,7 +6668,7 @@
       </p:pic>
       <p:sp>
         <p:nvSpPr>
-          <p:cNvPr id="93" name="Text 78"/>
+          <p:cNvPr id="89" name="Text 74"/>
           <p:cNvSpPr txBox="1"/>
           <p:nvPr/>
         </p:nvSpPr>

</xml_diff>